<commit_message>
Refaz os blocos 33-43 do ROTA e junta os repertórios em REPERTÓRIO/ com o COMPLETO.
- 33 A FESTA É COM ROTA DO CHOPP; 34-37 loops de vaneira 82/90/94/97;
  38-40 loops de marcha 135/138/140 (4 tempos de click antes da percussão);
  41-43 click de marcha 135/138/140. Saem os loops de fumpa.
- O bloco antigo A FESTA É COM O ROTA vai para o VS - LAB (bloco 2).
- Tira o solo da sanfona do bloco 4.
- REPERTÓRIO/: VS, AO VIVO e COMPLETO (gerado por
  scripts/montar_repertorio_completo.py); backups em Backups/.
- --sem-exports no adicionar_bloco.py e no remover_bloco.py.
- Saídas HWOUT/MASTERHWOUT para a Ui24 inalteradas.

Co-Authored-By: Claude Opus 5.5 <noreply@anthropic.com>
</commit_message>
<xml_diff>
--- a/VS - LAB/REPERTÓRIO/Repertório VS LAB.pptx
+++ b/VS - LAB/REPERTÓRIO/Repertório VS LAB.pptx
@@ -9,6 +9,7 @@
   </p:handoutMasterIdLst>
   <p:sldIdLst>
     <p:sldId id="480" r:id="rId2"/>
+    <p:sldId id="481" r:id="rId9"/>
   </p:sldIdLst>
   <p:sldSz cx="12192000" cy="6858000"/>
   <p:notesSz cx="6858000" cy="9144000"/>
@@ -6389,6 +6390,106 @@
 </p:sld>
 </file>
 
+<file path=ppt/slides/slide2.xml><?xml version="1.0" encoding="utf-8"?>
+<p:sld xmlns:a="http://schemas.openxmlformats.org/drawingml/2006/main" xmlns:r="http://schemas.openxmlformats.org/officeDocument/2006/relationships" xmlns:p="http://schemas.openxmlformats.org/presentationml/2006/main">
+  <p:cSld>
+    <p:spTree>
+      <p:nvGrpSpPr>
+        <p:cNvPr id="1" name=""/>
+        <p:cNvGrpSpPr/>
+        <p:nvPr/>
+      </p:nvGrpSpPr>
+      <p:grpSpPr>
+        <a:xfrm>
+          <a:off x="0" y="0"/>
+          <a:ext cx="0" cy="0"/>
+          <a:chOff x="0" y="0"/>
+          <a:chExt cx="0" cy="0"/>
+        </a:xfrm>
+      </p:grpSpPr>
+      <p:sp>
+        <p:nvSpPr>
+          <p:cNvPr id="3" name="Espaço Reservado para Conteúdo 2">
+            <a:extLst>
+              <a:ext uri="{FF2B5EF4-FFF2-40B4-BE49-F238E27FC236}">
+                <a16:creationId xmlns:a16="http://schemas.microsoft.com/office/drawing/2014/main" id="{7C70BAA2-54A1-BAA9-5EF9-9F93F22AE700}"/>
+              </a:ext>
+            </a:extLst>
+          </p:cNvPr>
+          <p:cNvSpPr>
+            <a:spLocks noGrp="1"/>
+          </p:cNvSpPr>
+          <p:nvPr>
+            <p:ph idx="1"/>
+          </p:nvPr>
+        </p:nvSpPr>
+        <p:spPr>
+          <a:xfrm>
+            <a:off x="10509" y="-3937"/>
+            <a:ext cx="12181491" cy="6861937"/>
+          </a:xfrm>
+        </p:spPr>
+        <p:txBody>
+          <a:bodyPr>
+            <a:noAutofit/>
+          </a:bodyPr>
+          <a:lstStyle/>
+          <a:p>
+            <a:pPr algn="ctr">
+              <a:lnSpc>
+                <a:spcPct val="100000"/>
+              </a:lnSpc>
+              <a:buNone/>
+            </a:pPr>
+            <a:r>
+              <a:rPr lang="en-US" sz="8800">
+                <a:solidFill>
+                  <a:srgbClr val="FF0000"/>
+                </a:solidFill>
+                <a:cs typeface="Arial" panose="020B0604020202020204" pitchFamily="34" charset="0"/>
+              </a:rPr>
+              <a:t>VS BLOCO 2</a:t>
+            </a:r>
+            <a:endParaRPr lang="en-US" sz="8800" dirty="0">
+              <a:solidFill>
+                <a:srgbClr val="FF0000"/>
+              </a:solidFill>
+              <a:cs typeface="Arial" panose="020B0604020202020204" pitchFamily="34" charset="0"/>
+            </a:endParaRPr>
+          </a:p>
+          <a:p>
+            <a:pPr marL="36000" indent="-252000" algn="ctr">
+              <a:lnSpc>
+                <a:spcPct val="100000"/>
+              </a:lnSpc>
+              <a:spcBef>
+                <a:spcPts val="0"/>
+              </a:spcBef>
+              <a:buNone/>
+            </a:pPr>
+            <a:r>
+              <a:rPr lang="pt-BR" sz="7200" dirty="0"/>
+              <a:t>A Festa É com o Rota </a:t>
+            </a:r>
+            <a:r>
+              <a:rPr lang="pt-BR" sz="7200" dirty="0">
+                <a:solidFill>
+                  <a:srgbClr val="FF0000"/>
+                </a:solidFill>
+              </a:rPr>
+              <a:t>??</a:t>
+            </a:r>
+          </a:p>
+        </p:txBody>
+      </p:sp>
+    </p:spTree>
+  </p:cSld>
+  <p:clrMapOvr>
+    <a:masterClrMapping/>
+  </p:clrMapOvr>
+</p:sld>
+</file>
+
 <file path=ppt/theme/theme1.xml><?xml version="1.0" encoding="utf-8"?>
 <a:theme xmlns:a="http://schemas.openxmlformats.org/drawingml/2006/main" name="Damask">
   <a:themeElements>

</xml_diff>